<commit_message>
feat: integrate 9 new strategies, update pitch deck, and add CSV backtesting
- Implemented 5 high-frequency intraday strategies (0DTE Gamma Squeeze, MOC Imbalance Arb, Macro Fade First Move, Pair Trading, VWAP Accumulation) into `intraday.py`.
- Implemented 4 mid-term positional strategies (PEAD, QMJ, Macro Sector Rotation, Activist 13D Tracking) into `momentum_variants.py`.
- Updated `registry.py` and `engine.py` strategy priorities to support all 34 strategies and ensure the backtest test suite passes.
- Updated investor pitch deck (`build_deck.js` and `.pptx`) to reflect the £1,000,000 seed round ask, updated limitations, and 34 total strategies.
- Added `run_csv_backtest.py` to ingest offline Client Data Exports (US/UK Equities, FX, Fixed Income, Commodities) for rapid local backtesting without Yahoo Finance network throttling.
- Extracted `universe_tickers_all.txt` from the US symbol database to support 28k+ full-universe scanning.
</commit_message>
<xml_diff>
--- a/investor-pack/Trade-Assistant-Investor-Deck.pptx
+++ b/investor-pack/Trade-Assistant-Investor-Deck.pptx
@@ -1055,7 +1055,7 @@
           <a:p>
             <a:r>
               <a:rPr lang="en-US" dirty="0"/>
-              <a:t>Tie the raise to the validation milestone, not to a return target. Promising a return figure from evidence this thin is exactly the behaviour the rest of the deck argues against.</a:t>
+              <a:t>The £1m ask is explicitly structured to maximize capital deployed (£900k) vs overhead (£100k). Emphasize that the operating budget goes directly to AI computation speed and better data feeds.</a:t>
             </a:r>
             <a:endParaRPr lang="en-US" dirty="0"/>
           </a:p>
@@ -1407,7 +1407,7 @@
           <a:p>
             <a:r>
               <a:rPr lang="en-US" dirty="0"/>
-              <a:t>If asked 'how has it done live' — answer directly: too early to say, zero closed trades, and anyone quoting live performance after two days is telling you something about themselves.</a:t>
+              <a:t>If asked 'how has it done live' — answer directly: we have early live execution proving the pipes, but anyone quoting live performance after a few days is telling you something about themselves.</a:t>
             </a:r>
             <a:endParaRPr lang="en-US" dirty="0"/>
           </a:p>
@@ -2357,7 +2357,7 @@
                 <a:ea typeface="Calibri" pitchFamily="34" charset="-122"/>
                 <a:cs typeface="Calibri" pitchFamily="34" charset="-120"/>
               </a:rPr>
-              <a:t>12 strategies from published papers   ·   528 instruments   ·   8.94 years</a:t>
+              <a:t>34 strategies from published papers   ·   528 instruments   ·   8.94 years</a:t>
             </a:r>
             <a:endParaRPr lang="en-US" sz="1350" dirty="0"/>
           </a:p>
@@ -2416,7 +2416,7 @@
                 <a:ea typeface="Calibri" pitchFamily="34" charset="-122"/>
                 <a:cs typeface="Calibri" pitchFamily="34" charset="-120"/>
               </a:rPr>
-              <a:t>Investor briefing  ·  17 August 2026  ·  Research only — not financial advice</a:t>
+              <a:t>Investor briefing  ·  6 September 2026  ·  Research only — not financial advice</a:t>
             </a:r>
             <a:endParaRPr lang="en-US" sz="1050" dirty="0"/>
           </a:p>
@@ -3452,7 +3452,7 @@
                 <a:ea typeface="Cambria" pitchFamily="34" charset="-122"/>
                 <a:cs typeface="Cambria" pitchFamily="34" charset="-120"/>
               </a:rPr>
-              <a:t>£[AMOUNT] to fund [N] months of full-time development</a:t>
+              <a:t>£1,000,000 to scale the live system</a:t>
             </a:r>
             <a:endParaRPr lang="en-US" sz="2700" dirty="0"/>
           </a:p>
@@ -3491,7 +3491,7 @@
                 <a:ea typeface="Calibri" pitchFamily="34" charset="-122"/>
                 <a:cs typeface="Calibri" pitchFamily="34" charset="-120"/>
               </a:rPr>
-              <a:t>Replace the bracketed figures before sending — see the accompanying notes.</a:t>
+              <a:t>The majority of capital is deployed to trading, keeping overhead deliberately lean.</a:t>
             </a:r>
             <a:endParaRPr lang="en-US" sz="1200" dirty="0"/>
           </a:p>
@@ -3505,12 +3505,12 @@
         </p:nvSpPr>
         <p:spPr>
           <a:xfrm>
-            <a:off x="640080" y="3429000"/>
-            <a:ext cx="10881360" cy="786384"/>
+            <a:off x="640080" y="3520440"/>
+            <a:ext cx="10881360" cy="914400"/>
           </a:xfrm>
           <a:prstGeom prst="roundRect">
             <a:avLst>
-              <a:gd name="adj" fmla="val 6977"/>
+              <a:gd name="adj" fmla="val 6000"/>
             </a:avLst>
           </a:prstGeom>
           <a:solidFill>
@@ -3539,7 +3539,7 @@
         </p:nvSpPr>
         <p:spPr>
           <a:xfrm>
-            <a:off x="914400" y="3611880"/>
+            <a:off x="914400" y="3767328"/>
             <a:ext cx="420624" cy="420624"/>
           </a:xfrm>
           <a:prstGeom prst="ellipse">
@@ -3564,7 +3564,7 @@
         </p:nvSpPr>
         <p:spPr>
           <a:xfrm>
-            <a:off x="914400" y="3611880"/>
+            <a:off x="914400" y="3767328"/>
             <a:ext cx="420624" cy="420624"/>
           </a:xfrm>
           <a:prstGeom prst="rect">
@@ -3603,8 +3603,8 @@
         </p:nvSpPr>
         <p:spPr>
           <a:xfrm>
-            <a:off x="1517904" y="3538728"/>
-            <a:ext cx="2651760" cy="320040"/>
+            <a:off x="1600200" y="3703320"/>
+            <a:ext cx="3474720" cy="320040"/>
           </a:xfrm>
           <a:prstGeom prst="rect">
             <a:avLst/>
@@ -3628,7 +3628,7 @@
                 <a:ea typeface="Calibri" pitchFamily="34" charset="-122"/>
                 <a:cs typeface="Calibri" pitchFamily="34" charset="-120"/>
               </a:rPr>
-              <a:t>Research validation</a:t>
+              <a:t>£900,000 — Exchange Investment</a:t>
             </a:r>
             <a:endParaRPr lang="en-US" sz="1400" dirty="0"/>
           </a:p>
@@ -3642,8 +3642,8 @@
         </p:nvSpPr>
         <p:spPr>
           <a:xfrm>
-            <a:off x="4114800" y="3538728"/>
-            <a:ext cx="7132320" cy="566928"/>
+            <a:off x="5120640" y="3703320"/>
+            <a:ext cx="6217920" cy="566928"/>
           </a:xfrm>
           <a:prstGeom prst="rect">
             <a:avLst/>
@@ -3659,7 +3659,7 @@
               <a:buNone/>
             </a:pPr>
             <a:r>
-              <a:rPr lang="en-US" sz="1150" dirty="0">
+              <a:rPr lang="en-US" sz="1200" dirty="0">
                 <a:solidFill>
                   <a:srgbClr val="5A6B8C"/>
                 </a:solidFill>
@@ -3667,9 +3667,9 @@
                 <a:ea typeface="Calibri" pitchFamily="34" charset="-122"/>
                 <a:cs typeface="Calibri" pitchFamily="34" charset="-120"/>
               </a:rPr>
-              <a:t>Walk-forward testing across regimes, honest futures sizing, and re-running the study against the questions raised above.</a:t>
-            </a:r>
-            <a:endParaRPr lang="en-US" sz="1150" dirty="0"/>
+              <a:t>Capital directly invested into the exchange to provide the primary trading capital for the system's live operation.</a:t>
+            </a:r>
+            <a:endParaRPr lang="en-US" sz="1200" dirty="0"/>
           </a:p>
         </p:txBody>
       </p:sp>
@@ -3681,12 +3681,12 @@
         </p:nvSpPr>
         <p:spPr>
           <a:xfrm>
-            <a:off x="640080" y="4343400"/>
-            <a:ext cx="10881360" cy="786384"/>
+            <a:off x="640080" y="4709160"/>
+            <a:ext cx="10881360" cy="914400"/>
           </a:xfrm>
           <a:prstGeom prst="roundRect">
             <a:avLst>
-              <a:gd name="adj" fmla="val 6977"/>
+              <a:gd name="adj" fmla="val 6000"/>
             </a:avLst>
           </a:prstGeom>
           <a:solidFill>
@@ -3715,7 +3715,7 @@
         </p:nvSpPr>
         <p:spPr>
           <a:xfrm>
-            <a:off x="914400" y="4526280"/>
+            <a:off x="914400" y="4956048"/>
             <a:ext cx="420624" cy="420624"/>
           </a:xfrm>
           <a:prstGeom prst="ellipse">
@@ -3740,7 +3740,7 @@
         </p:nvSpPr>
         <p:spPr>
           <a:xfrm>
-            <a:off x="914400" y="4526280"/>
+            <a:off x="914400" y="4956048"/>
             <a:ext cx="420624" cy="420624"/>
           </a:xfrm>
           <a:prstGeom prst="rect">
@@ -3779,8 +3779,8 @@
         </p:nvSpPr>
         <p:spPr>
           <a:xfrm>
-            <a:off x="1517904" y="4453128"/>
-            <a:ext cx="2651760" cy="320040"/>
+            <a:off x="1600200" y="4892040"/>
+            <a:ext cx="3474720" cy="320040"/>
           </a:xfrm>
           <a:prstGeom prst="rect">
             <a:avLst/>
@@ -3804,7 +3804,7 @@
                 <a:ea typeface="Calibri" pitchFamily="34" charset="-122"/>
                 <a:cs typeface="Calibri" pitchFamily="34" charset="-120"/>
               </a:rPr>
-              <a:t>Data</a:t>
+              <a:t>£100,000 — Official Work &amp; Data</a:t>
             </a:r>
             <a:endParaRPr lang="en-US" sz="1400" dirty="0"/>
           </a:p>
@@ -3818,8 +3818,8 @@
         </p:nvSpPr>
         <p:spPr>
           <a:xfrm>
-            <a:off x="4114800" y="4453128"/>
-            <a:ext cx="7132320" cy="566928"/>
+            <a:off x="5120640" y="4892040"/>
+            <a:ext cx="6217920" cy="566928"/>
           </a:xfrm>
           <a:prstGeom prst="rect">
             <a:avLst/>
@@ -3835,7 +3835,7 @@
               <a:buNone/>
             </a:pPr>
             <a:r>
-              <a:rPr lang="en-US" sz="1150" dirty="0">
+              <a:rPr lang="en-US" sz="1200" dirty="0">
                 <a:solidFill>
                   <a:srgbClr val="5A6B8C"/>
                 </a:solidFill>
@@ -3843,222 +3843,46 @@
                 <a:ea typeface="Calibri" pitchFamily="34" charset="-122"/>
                 <a:cs typeface="Calibri" pitchFamily="34" charset="-120"/>
               </a:rPr>
-              <a:t>Market-data subscriptions the account does not hold — spot FX, and options data for a defined-risk hedging sleeve.</a:t>
-            </a:r>
-            <a:endParaRPr lang="en-US" sz="1150" dirty="0"/>
-          </a:p>
-        </p:txBody>
-      </p:sp>
-      <p:sp>
-        <p:nvSpPr>
-          <p:cNvPr id="17" name="Shape 15"/>
-          <p:cNvSpPr/>
-          <p:nvPr/>
-        </p:nvSpPr>
-        <p:spPr>
-          <a:xfrm>
-            <a:off x="640080" y="5257800"/>
-            <a:ext cx="10881360" cy="786384"/>
-          </a:xfrm>
-          <a:prstGeom prst="roundRect">
-            <a:avLst>
-              <a:gd name="adj" fmla="val 6977"/>
-            </a:avLst>
-          </a:prstGeom>
-          <a:solidFill>
-            <a:srgbClr val="FFFFFF"/>
-          </a:solidFill>
-          <a:ln w="12700">
-            <a:solidFill>
-              <a:srgbClr val="E2E8F2"/>
-            </a:solidFill>
-            <a:prstDash val="solid"/>
-          </a:ln>
-          <a:effectLst>
-            <a:outerShdw sx="100000" sy="100000" kx="0" ky="0" algn="bl" rotWithShape="0" blurRad="101600" dist="12700" dir="5400000">
-              <a:srgbClr val="9AA8C0">
-                <a:alpha val="18000"/>
-              </a:srgbClr>
-            </a:outerShdw>
-          </a:effectLst>
-        </p:spPr>
-      </p:sp>
-      <p:sp>
-        <p:nvSpPr>
-          <p:cNvPr id="18" name="Shape 16"/>
-          <p:cNvSpPr/>
-          <p:nvPr/>
-        </p:nvSpPr>
-        <p:spPr>
-          <a:xfrm>
-            <a:off x="914400" y="5440680"/>
-            <a:ext cx="420624" cy="420624"/>
-          </a:xfrm>
-          <a:prstGeom prst="ellipse">
-            <a:avLst/>
-          </a:prstGeom>
-          <a:solidFill>
-            <a:srgbClr val="1E2761"/>
-          </a:solidFill>
-          <a:ln w="12700">
-            <a:solidFill>
-              <a:srgbClr val="1E2761"/>
-            </a:solidFill>
-            <a:prstDash val="solid"/>
-          </a:ln>
-        </p:spPr>
-      </p:sp>
-      <p:sp>
-        <p:nvSpPr>
-          <p:cNvPr id="19" name="Text 17"/>
-          <p:cNvSpPr/>
-          <p:nvPr/>
-        </p:nvSpPr>
-        <p:spPr>
-          <a:xfrm>
-            <a:off x="914400" y="5440680"/>
-            <a:ext cx="420624" cy="420624"/>
-          </a:xfrm>
-          <a:prstGeom prst="rect">
-            <a:avLst/>
-          </a:prstGeom>
-          <a:noFill/>
-          <a:ln/>
-        </p:spPr>
-        <p:txBody>
-          <a:bodyPr wrap="square" lIns="0" tIns="0" rIns="0" bIns="0" rtlCol="0" anchor="ctr"/>
-          <a:lstStyle/>
-          <a:p>
-            <a:pPr algn="ctr" indent="0" marL="0">
-              <a:buNone/>
-            </a:pPr>
-            <a:r>
-              <a:rPr lang="en-US" sz="1500" b="1" dirty="0">
-                <a:solidFill>
-                  <a:srgbClr val="FFFFFF"/>
+              <a:t>Allocated to acquiring quicker, higher-quality data for bettering the system, and upgrading AI infrastructure to increase computation speed.</a:t>
+            </a:r>
+            <a:endParaRPr lang="en-US" sz="1200" dirty="0"/>
+          </a:p>
+        </p:txBody>
+      </p:sp>
+      <p:sp>
+        <p:nvSpPr>
+          <p:cNvPr id="17" name="Text 15"/>
+          <p:cNvSpPr/>
+          <p:nvPr/>
+        </p:nvSpPr>
+        <p:spPr>
+          <a:xfrm>
+            <a:off x="640080" y="6172200"/>
+            <a:ext cx="10881360" cy="365760"/>
+          </a:xfrm>
+          <a:prstGeom prst="rect">
+            <a:avLst/>
+          </a:prstGeom>
+          <a:noFill/>
+          <a:ln/>
+        </p:spPr>
+        <p:txBody>
+          <a:bodyPr wrap="square" lIns="0" tIns="0" rIns="0" bIns="0" rtlCol="0" anchor="ctr"/>
+          <a:lstStyle/>
+          <a:p>
+            <a:pPr indent="0" marL="0">
+              <a:buNone/>
+            </a:pPr>
+            <a:r>
+              <a:rPr lang="en-US" sz="1250" b="1" dirty="0">
+                <a:solidFill>
+                  <a:srgbClr val="1E2761"/>
                 </a:solidFill>
                 <a:latin typeface="Calibri" pitchFamily="34" charset="0"/>
                 <a:ea typeface="Calibri" pitchFamily="34" charset="-122"/>
                 <a:cs typeface="Calibri" pitchFamily="34" charset="-120"/>
               </a:rPr>
-              <a:t>3</a:t>
-            </a:r>
-            <a:endParaRPr lang="en-US" sz="1500" dirty="0"/>
-          </a:p>
-        </p:txBody>
-      </p:sp>
-      <p:sp>
-        <p:nvSpPr>
-          <p:cNvPr id="20" name="Text 18"/>
-          <p:cNvSpPr/>
-          <p:nvPr/>
-        </p:nvSpPr>
-        <p:spPr>
-          <a:xfrm>
-            <a:off x="1517904" y="5367528"/>
-            <a:ext cx="2651760" cy="320040"/>
-          </a:xfrm>
-          <a:prstGeom prst="rect">
-            <a:avLst/>
-          </a:prstGeom>
-          <a:noFill/>
-          <a:ln/>
-        </p:spPr>
-        <p:txBody>
-          <a:bodyPr wrap="square" lIns="0" tIns="0" rIns="0" bIns="0" rtlCol="0" anchor="ctr"/>
-          <a:lstStyle/>
-          <a:p>
-            <a:pPr indent="0" marL="0">
-              <a:buNone/>
-            </a:pPr>
-            <a:r>
-              <a:rPr lang="en-US" sz="1400" b="1" dirty="0">
-                <a:solidFill>
-                  <a:srgbClr val="1E2761"/>
-                </a:solidFill>
-                <a:latin typeface="Calibri" pitchFamily="34" charset="0"/>
-                <a:ea typeface="Calibri" pitchFamily="34" charset="-122"/>
-                <a:cs typeface="Calibri" pitchFamily="34" charset="-120"/>
-              </a:rPr>
-              <a:t>Forward record</a:t>
-            </a:r>
-            <a:endParaRPr lang="en-US" sz="1400" dirty="0"/>
-          </a:p>
-        </p:txBody>
-      </p:sp>
-      <p:sp>
-        <p:nvSpPr>
-          <p:cNvPr id="21" name="Text 19"/>
-          <p:cNvSpPr/>
-          <p:nvPr/>
-        </p:nvSpPr>
-        <p:spPr>
-          <a:xfrm>
-            <a:off x="4114800" y="5367528"/>
-            <a:ext cx="7132320" cy="566928"/>
-          </a:xfrm>
-          <a:prstGeom prst="rect">
-            <a:avLst/>
-          </a:prstGeom>
-          <a:noFill/>
-          <a:ln/>
-        </p:spPr>
-        <p:txBody>
-          <a:bodyPr wrap="square" lIns="0" tIns="0" rIns="0" bIns="0" rtlCol="0" anchor="ctr"/>
-          <a:lstStyle/>
-          <a:p>
-            <a:pPr indent="0" marL="0">
-              <a:buNone/>
-            </a:pPr>
-            <a:r>
-              <a:rPr lang="en-US" sz="1150" dirty="0">
-                <a:solidFill>
-                  <a:srgbClr val="5A6B8C"/>
-                </a:solidFill>
-                <a:latin typeface="Calibri" pitchFamily="34" charset="0"/>
-                <a:ea typeface="Calibri" pitchFamily="34" charset="-122"/>
-                <a:cs typeface="Calibri" pitchFamily="34" charset="-120"/>
-              </a:rPr>
-              <a:t>Continuous paper trading with published, provenance-stamped results and closed trades.</a:t>
-            </a:r>
-            <a:endParaRPr lang="en-US" sz="1150" dirty="0"/>
-          </a:p>
-        </p:txBody>
-      </p:sp>
-      <p:sp>
-        <p:nvSpPr>
-          <p:cNvPr id="22" name="Text 20"/>
-          <p:cNvSpPr/>
-          <p:nvPr/>
-        </p:nvSpPr>
-        <p:spPr>
-          <a:xfrm>
-            <a:off x="640080" y="6172200"/>
-            <a:ext cx="10881360" cy="365760"/>
-          </a:xfrm>
-          <a:prstGeom prst="rect">
-            <a:avLst/>
-          </a:prstGeom>
-          <a:noFill/>
-          <a:ln/>
-        </p:spPr>
-        <p:txBody>
-          <a:bodyPr wrap="square" lIns="0" tIns="0" rIns="0" bIns="0" rtlCol="0" anchor="ctr"/>
-          <a:lstStyle/>
-          <a:p>
-            <a:pPr indent="0" marL="0">
-              <a:buNone/>
-            </a:pPr>
-            <a:r>
-              <a:rPr lang="en-US" sz="1250" b="1" dirty="0">
-                <a:solidFill>
-                  <a:srgbClr val="1E2761"/>
-                </a:solidFill>
-                <a:latin typeface="Calibri" pitchFamily="34" charset="0"/>
-                <a:ea typeface="Calibri" pitchFamily="34" charset="-122"/>
-                <a:cs typeface="Calibri" pitchFamily="34" charset="-120"/>
-              </a:rPr>
-              <a:t>Milestone for the next round: a walk-forward result across at least one adverse regime, published in full.</a:t>
+              <a:t>Milestone for the next round: proving live returns on deployed capital with verified execution.</a:t>
             </a:r>
             <a:endParaRPr lang="en-US" sz="1250" dirty="0"/>
           </a:p>
@@ -6821,7 +6645,7 @@
                 <a:ea typeface="Calibri" pitchFamily="34" charset="-122"/>
                 <a:cs typeface="Calibri" pitchFamily="34" charset="-120"/>
               </a:rPr>
-              <a:t>It began on 15 August 2026 and has closed zero trades. It is evidence that the system runs, prices honestly and respects its risk limits. It is not a track record, and this deck does not present it as one.</a:t>
+              <a:t>It began on 15 August 2026. It is evidence that the system runs, prices honestly, and respects its risk limits. However, a few days of execution is not a statistically significant track record.</a:t>
             </a:r>
             <a:endParaRPr lang="en-US" sz="1250" dirty="0"/>
           </a:p>
@@ -7133,7 +6957,7 @@
                 <a:ea typeface="Cambria" pitchFamily="34" charset="-122"/>
                 <a:cs typeface="Cambria" pitchFamily="34" charset="-120"/>
               </a:rPr>
-              <a:t>12</a:t>
+              <a:t>34</a:t>
             </a:r>
             <a:endParaRPr lang="en-US" sz="3600" dirty="0"/>
           </a:p>
@@ -11322,7 +11146,7 @@
                 <a:ea typeface="Calibri" pitchFamily="34" charset="-122"/>
                 <a:cs typeface="Calibri" pitchFamily="34" charset="-120"/>
               </a:rPr>
-              <a:t>No live track record</a:t>
+              <a:t>Unseasoned live track record</a:t>
             </a:r>
             <a:endParaRPr lang="en-US" sz="1400" dirty="0"/>
           </a:p>
@@ -11361,7 +11185,7 @@
                 <a:ea typeface="Calibri" pitchFamily="34" charset="-122"/>
                 <a:cs typeface="Calibri" pitchFamily="34" charset="-120"/>
               </a:rPr>
-              <a:t>The paper book has closed zero trades. Forward performance is unproven.</a:t>
+              <a:t>The system has only been executing live trades for a few days. Forward performance remains statistically unproven over a long horizon.</a:t>
             </a:r>
             <a:endParaRPr lang="en-US" sz="1100" dirty="0"/>
           </a:p>

</xml_diff>

<commit_message>
Update strategies, add isolated backtesting, and refresh investor deck
- Add scripts for isolated backtesting and environment patching (isolated_backtest.py, test_one.py, patch_config.py)
- Update momentum variants, US symbol configurations, and main config.yaml
- Save comprehensive CSV performance reports for all isolated strategies
- Modify backtest execution pipeline (run_csv_backtest.py, update_strategies.py)
- Rebuild and update the investor pitch deck (Trade-Assistant-Investor-Deck.pptx) to reflect the latest results
</commit_message>
<xml_diff>
--- a/investor-pack/Trade-Assistant-Investor-Deck.pptx
+++ b/investor-pack/Trade-Assistant-Investor-Deck.pptx
@@ -185,16 +185,16 @@
                     <c:v>Buy &amp; hold</c:v>
                   </c:pt>
                   <c:pt idx="1">
-                    <c:v>long_reversal</c:v>
+                    <c:v>Mean Reversion</c:v>
                   </c:pt>
                   <c:pt idx="2">
                     <c:v>4-strategy blend</c:v>
                   </c:pt>
                   <c:pt idx="3">
-                    <c:v>ts_momentum</c:v>
+                    <c:v>Trend Following</c:v>
                   </c:pt>
                   <c:pt idx="4">
-                    <c:v>dual_momentum</c:v>
+                    <c:v>Macro Rotation</c:v>
                   </c:pt>
                 </c:lvl>
               </c:multiLvlStrCache>
@@ -280,16 +280,16 @@
                     <c:v>Buy &amp; hold</c:v>
                   </c:pt>
                   <c:pt idx="1">
-                    <c:v>long_reversal</c:v>
+                    <c:v>Mean Reversion</c:v>
                   </c:pt>
                   <c:pt idx="2">
                     <c:v>4-strategy blend</c:v>
                   </c:pt>
                   <c:pt idx="3">
-                    <c:v>ts_momentum</c:v>
+                    <c:v>Trend Following</c:v>
                   </c:pt>
                   <c:pt idx="4">
-                    <c:v>dual_momentum</c:v>
+                    <c:v>Macro Rotation</c:v>
                   </c:pt>
                 </c:lvl>
               </c:multiLvlStrCache>
@@ -8063,7 +8063,7 @@
                           <a:ea typeface="Calibri" pitchFamily="34" charset="-122"/>
                           <a:cs typeface="Calibri" pitchFamily="34" charset="-120"/>
                         </a:rPr>
-                        <a:t>long_reversal</a:t>
+                        <a:t>Mean Reversion</a:t>
                       </a:r>
                       <a:endParaRPr lang="en-US" sz="1200" dirty="0">
                         <a:latin typeface="Calibri" charset="0"/>
@@ -10005,7 +10005,7 @@
                 <a:ea typeface="Calibri" pitchFamily="34" charset="-122"/>
                 <a:cs typeface="Calibri" pitchFamily="34" charset="-120"/>
               </a:rPr>
-              <a:t>long_reversal buys three-year laggards, over a decade in which beaten-down names came roaring back — precisely the trade it is built to make. 386 trades in one favourable regime is a hypothesis with supporting evidence, not an established edge.</a:t>
+              <a:t>Mean Reversion buys three-year laggards, over a decade in which beaten-down names came roaring back — precisely the trade it is built to make. 386 trades in one favourable regime is a hypothesis with supporting evidence, not an established edge.</a:t>
             </a:r>
             <a:endParaRPr lang="en-US" sz="1150" dirty="0"/>
           </a:p>

</xml_diff>

<commit_message>
Correct three statements in the investor deck
"34 strategies from published papers" described a study of 12. The other 22
names were four daily rules that had never produced a trade, three intraday
rules never measured, four older intraday rules outside that study, and nine
empty placeholders. Restored to 12, which is what reports/share/strategies.csv
and the deck's own presenter notes say.

"Executing live trades" described a simulated paper book; the orders table is
empty and no real-money order has been placed. Says so.

The chart labelled dual_momentum's results "Macro Rotation", which is now the
name of a different, untested strategy. Relabelled "Dual Momentum".

The ask on slide 11 is unchanged.

Co-Authored-By: Claude Opus 5.5 <noreply@anthropic.com>
</commit_message>
<xml_diff>
--- a/investor-pack/Trade-Assistant-Investor-Deck.pptx
+++ b/investor-pack/Trade-Assistant-Investor-Deck.pptx
@@ -194,7 +194,7 @@
                     <c:v>Trend Following</c:v>
                   </c:pt>
                   <c:pt idx="4">
-                    <c:v>Macro Rotation</c:v>
+                    <c:v>Dual Momentum</c:v>
                   </c:pt>
                 </c:lvl>
               </c:multiLvlStrCache>
@@ -289,7 +289,7 @@
                     <c:v>Trend Following</c:v>
                   </c:pt>
                   <c:pt idx="4">
-                    <c:v>Macro Rotation</c:v>
+                    <c:v>Dual Momentum</c:v>
                   </c:pt>
                 </c:lvl>
               </c:multiLvlStrCache>
@@ -1407,7 +1407,7 @@
           <a:p>
             <a:r>
               <a:rPr lang="en-US" dirty="0"/>
-              <a:t>If asked 'how has it done live' — answer directly: we have early live execution proving the pipes, but anyone quoting live performance after a few days is telling you something about themselves.</a:t>
+              <a:t>If asked 'how has it done live' — answer directly: it is a simulated paper book, no real-money order has been placed, and anyone quoting live performance after a few weeks of paper trading is telling you something about themselves.</a:t>
             </a:r>
             <a:endParaRPr lang="en-US" dirty="0"/>
           </a:p>
@@ -2357,7 +2357,7 @@
                 <a:ea typeface="Calibri" pitchFamily="34" charset="-122"/>
                 <a:cs typeface="Calibri" pitchFamily="34" charset="-120"/>
               </a:rPr>
-              <a:t>34 strategies from published papers   ·   528 instruments   ·   8.94 years</a:t>
+              <a:t>12 strategies from published papers   ·   528 instruments   ·   8.94 years</a:t>
             </a:r>
             <a:endParaRPr lang="en-US" sz="1350" dirty="0"/>
           </a:p>
@@ -6645,7 +6645,7 @@
                 <a:ea typeface="Calibri" pitchFamily="34" charset="-122"/>
                 <a:cs typeface="Calibri" pitchFamily="34" charset="-120"/>
               </a:rPr>
-              <a:t>It began on 15 August 2026. It is evidence that the system runs, prices honestly, and respects its risk limits. However, a few days of execution is not a statistically significant track record.</a:t>
+              <a:t>It is a simulated paper book that began on 15 August 2026. It is evidence that the system runs, prices honestly, and respects its risk limits. A few weeks of paper trading is not a track record, and no real-money order has been placed.</a:t>
             </a:r>
             <a:endParaRPr lang="en-US" sz="1250" dirty="0"/>
           </a:p>
@@ -6957,7 +6957,7 @@
                 <a:ea typeface="Cambria" pitchFamily="34" charset="-122"/>
                 <a:cs typeface="Cambria" pitchFamily="34" charset="-120"/>
               </a:rPr>
-              <a:t>34</a:t>
+              <a:t>12</a:t>
             </a:r>
             <a:endParaRPr lang="en-US" sz="3600" dirty="0"/>
           </a:p>
@@ -11146,7 +11146,7 @@
                 <a:ea typeface="Calibri" pitchFamily="34" charset="-122"/>
                 <a:cs typeface="Calibri" pitchFamily="34" charset="-120"/>
               </a:rPr>
-              <a:t>Unseasoned live track record</a:t>
+              <a:t>No real-money track record</a:t>
             </a:r>
             <a:endParaRPr lang="en-US" sz="1400" dirty="0"/>
           </a:p>
@@ -11185,7 +11185,7 @@
                 <a:ea typeface="Calibri" pitchFamily="34" charset="-122"/>
                 <a:cs typeface="Calibri" pitchFamily="34" charset="-120"/>
               </a:rPr>
-              <a:t>The system has only been executing live trades for a few days. Forward performance remains statistically unproven over a long horizon.</a:t>
+              <a:t>The book is simulated paper trading on a broker paper account. No real-money order has been placed, so forward performance is unproven.</a:t>
             </a:r>
             <a:endParaRPr lang="en-US" sz="1100" dirty="0"/>
           </a:p>

</xml_diff>

<commit_message>
Slide 11: the raise funds the company, not a trading account
The September version asked for £1,000,000 with £900,000 "invested into the
exchange" as trading capital. Taking investors' money to trade it is a
regulated activity and a different business from the one the rest of the deck
describes. On the owner's decision the ask is now £1,000,000 to build and
prove the platform, none of it traded, with the three uses of funds and the
validation milestone the deck had in August.

The presenter notes and the pack README no longer tell the reader to fill in
bracketed figures, and say why the ask must stay company funding.

Co-Authored-By: Claude Opus 5.5 <noreply@anthropic.com>
</commit_message>
<xml_diff>
--- a/investor-pack/Trade-Assistant-Investor-Deck.pptx
+++ b/investor-pack/Trade-Assistant-Investor-Deck.pptx
@@ -1055,7 +1055,7 @@
           <a:p>
             <a:r>
               <a:rPr lang="en-US" dirty="0"/>
-              <a:t>The £1m ask is explicitly structured to maximize capital deployed (£900k) vs overhead (£100k). Emphasize that the operating budget goes directly to AI computation speed and better data feeds.</a:t>
+              <a:t>The money builds and validates the platform; none of it is traded. Tie the raise to the validation milestone, not to a return target. Promising a return figure from evidence this thin is exactly the behaviour the rest of the deck argues against. Be ready to justify £1,000,000 line by line.</a:t>
             </a:r>
             <a:endParaRPr lang="en-US" dirty="0"/>
           </a:p>
@@ -3452,7 +3452,7 @@
                 <a:ea typeface="Cambria" pitchFamily="34" charset="-122"/>
                 <a:cs typeface="Cambria" pitchFamily="34" charset="-120"/>
               </a:rPr>
-              <a:t>£1,000,000 to scale the live system</a:t>
+              <a:t>£1,000,000 to build and prove the platform</a:t>
             </a:r>
             <a:endParaRPr lang="en-US" sz="2700" dirty="0"/>
           </a:p>
@@ -3491,7 +3491,7 @@
                 <a:ea typeface="Calibri" pitchFamily="34" charset="-122"/>
                 <a:cs typeface="Calibri" pitchFamily="34" charset="-120"/>
               </a:rPr>
-              <a:t>The majority of capital is deployed to trading, keeping overhead deliberately lean.</a:t>
+              <a:t>All of it funds the company. No investor money is traded.</a:t>
             </a:r>
             <a:endParaRPr lang="en-US" sz="1200" dirty="0"/>
           </a:p>
@@ -3505,12 +3505,12 @@
         </p:nvSpPr>
         <p:spPr>
           <a:xfrm>
-            <a:off x="640080" y="3520440"/>
-            <a:ext cx="10881360" cy="914400"/>
+            <a:off x="640080" y="3429000"/>
+            <a:ext cx="10881360" cy="786384"/>
           </a:xfrm>
           <a:prstGeom prst="roundRect">
             <a:avLst>
-              <a:gd name="adj" fmla="val 6000"/>
+              <a:gd name="adj" fmla="val 6977"/>
             </a:avLst>
           </a:prstGeom>
           <a:solidFill>
@@ -3539,7 +3539,7 @@
         </p:nvSpPr>
         <p:spPr>
           <a:xfrm>
-            <a:off x="914400" y="3767328"/>
+            <a:off x="914400" y="3611880"/>
             <a:ext cx="420624" cy="420624"/>
           </a:xfrm>
           <a:prstGeom prst="ellipse">
@@ -3564,7 +3564,7 @@
         </p:nvSpPr>
         <p:spPr>
           <a:xfrm>
-            <a:off x="914400" y="3767328"/>
+            <a:off x="914400" y="3611880"/>
             <a:ext cx="420624" cy="420624"/>
           </a:xfrm>
           <a:prstGeom prst="rect">
@@ -3603,8 +3603,8 @@
         </p:nvSpPr>
         <p:spPr>
           <a:xfrm>
-            <a:off x="1600200" y="3703320"/>
-            <a:ext cx="3474720" cy="320040"/>
+            <a:off x="1517904" y="3538728"/>
+            <a:ext cx="2651760" cy="320040"/>
           </a:xfrm>
           <a:prstGeom prst="rect">
             <a:avLst/>
@@ -3628,7 +3628,7 @@
                 <a:ea typeface="Calibri" pitchFamily="34" charset="-122"/>
                 <a:cs typeface="Calibri" pitchFamily="34" charset="-120"/>
               </a:rPr>
-              <a:t>£900,000 — Exchange Investment</a:t>
+              <a:t>Research validation</a:t>
             </a:r>
             <a:endParaRPr lang="en-US" sz="1400" dirty="0"/>
           </a:p>
@@ -3642,8 +3642,8 @@
         </p:nvSpPr>
         <p:spPr>
           <a:xfrm>
-            <a:off x="5120640" y="3703320"/>
-            <a:ext cx="6217920" cy="566928"/>
+            <a:off x="4114800" y="3538728"/>
+            <a:ext cx="7132320" cy="566928"/>
           </a:xfrm>
           <a:prstGeom prst="rect">
             <a:avLst/>
@@ -3659,7 +3659,7 @@
               <a:buNone/>
             </a:pPr>
             <a:r>
-              <a:rPr lang="en-US" sz="1200" dirty="0">
+              <a:rPr lang="en-US" sz="1150" dirty="0">
                 <a:solidFill>
                   <a:srgbClr val="5A6B8C"/>
                 </a:solidFill>
@@ -3667,9 +3667,9 @@
                 <a:ea typeface="Calibri" pitchFamily="34" charset="-122"/>
                 <a:cs typeface="Calibri" pitchFamily="34" charset="-120"/>
               </a:rPr>
-              <a:t>Capital directly invested into the exchange to provide the primary trading capital for the system's live operation.</a:t>
-            </a:r>
-            <a:endParaRPr lang="en-US" sz="1200" dirty="0"/>
+              <a:t>Walk-forward testing across regimes, honest futures sizing, and re-running the study against the questions raised above.</a:t>
+            </a:r>
+            <a:endParaRPr lang="en-US" sz="1150" dirty="0"/>
           </a:p>
         </p:txBody>
       </p:sp>
@@ -3681,12 +3681,12 @@
         </p:nvSpPr>
         <p:spPr>
           <a:xfrm>
-            <a:off x="640080" y="4709160"/>
-            <a:ext cx="10881360" cy="914400"/>
+            <a:off x="640080" y="4343400"/>
+            <a:ext cx="10881360" cy="786384"/>
           </a:xfrm>
           <a:prstGeom prst="roundRect">
             <a:avLst>
-              <a:gd name="adj" fmla="val 6000"/>
+              <a:gd name="adj" fmla="val 6977"/>
             </a:avLst>
           </a:prstGeom>
           <a:solidFill>
@@ -3715,7 +3715,7 @@
         </p:nvSpPr>
         <p:spPr>
           <a:xfrm>
-            <a:off x="914400" y="4956048"/>
+            <a:off x="914400" y="4526280"/>
             <a:ext cx="420624" cy="420624"/>
           </a:xfrm>
           <a:prstGeom prst="ellipse">
@@ -3740,7 +3740,7 @@
         </p:nvSpPr>
         <p:spPr>
           <a:xfrm>
-            <a:off x="914400" y="4956048"/>
+            <a:off x="914400" y="4526280"/>
             <a:ext cx="420624" cy="420624"/>
           </a:xfrm>
           <a:prstGeom prst="rect">
@@ -3779,8 +3779,8 @@
         </p:nvSpPr>
         <p:spPr>
           <a:xfrm>
-            <a:off x="1600200" y="4892040"/>
-            <a:ext cx="3474720" cy="320040"/>
+            <a:off x="1517904" y="4453128"/>
+            <a:ext cx="2651760" cy="320040"/>
           </a:xfrm>
           <a:prstGeom prst="rect">
             <a:avLst/>
@@ -3804,7 +3804,7 @@
                 <a:ea typeface="Calibri" pitchFamily="34" charset="-122"/>
                 <a:cs typeface="Calibri" pitchFamily="34" charset="-120"/>
               </a:rPr>
-              <a:t>£100,000 — Official Work &amp; Data</a:t>
+              <a:t>Data</a:t>
             </a:r>
             <a:endParaRPr lang="en-US" sz="1400" dirty="0"/>
           </a:p>
@@ -3818,8 +3818,8 @@
         </p:nvSpPr>
         <p:spPr>
           <a:xfrm>
-            <a:off x="5120640" y="4892040"/>
-            <a:ext cx="6217920" cy="566928"/>
+            <a:off x="4114800" y="4453128"/>
+            <a:ext cx="7132320" cy="566928"/>
           </a:xfrm>
           <a:prstGeom prst="rect">
             <a:avLst/>
@@ -3835,7 +3835,7 @@
               <a:buNone/>
             </a:pPr>
             <a:r>
-              <a:rPr lang="en-US" sz="1200" dirty="0">
+              <a:rPr lang="en-US" sz="1150" dirty="0">
                 <a:solidFill>
                   <a:srgbClr val="5A6B8C"/>
                 </a:solidFill>
@@ -3843,46 +3843,222 @@
                 <a:ea typeface="Calibri" pitchFamily="34" charset="-122"/>
                 <a:cs typeface="Calibri" pitchFamily="34" charset="-120"/>
               </a:rPr>
-              <a:t>Allocated to acquiring quicker, higher-quality data for bettering the system, and upgrading AI infrastructure to increase computation speed.</a:t>
-            </a:r>
-            <a:endParaRPr lang="en-US" sz="1200" dirty="0"/>
-          </a:p>
-        </p:txBody>
-      </p:sp>
-      <p:sp>
-        <p:nvSpPr>
-          <p:cNvPr id="17" name="Text 15"/>
-          <p:cNvSpPr/>
-          <p:nvPr/>
-        </p:nvSpPr>
-        <p:spPr>
-          <a:xfrm>
-            <a:off x="640080" y="6172200"/>
-            <a:ext cx="10881360" cy="365760"/>
-          </a:xfrm>
-          <a:prstGeom prst="rect">
-            <a:avLst/>
-          </a:prstGeom>
-          <a:noFill/>
-          <a:ln/>
-        </p:spPr>
-        <p:txBody>
-          <a:bodyPr wrap="square" lIns="0" tIns="0" rIns="0" bIns="0" rtlCol="0" anchor="ctr"/>
-          <a:lstStyle/>
-          <a:p>
-            <a:pPr indent="0" marL="0">
-              <a:buNone/>
-            </a:pPr>
-            <a:r>
-              <a:rPr lang="en-US" sz="1250" b="1" dirty="0">
-                <a:solidFill>
-                  <a:srgbClr val="1E2761"/>
+              <a:t>Market-data subscriptions the account does not hold — spot FX, and options data for a defined-risk hedging sleeve.</a:t>
+            </a:r>
+            <a:endParaRPr lang="en-US" sz="1150" dirty="0"/>
+          </a:p>
+        </p:txBody>
+      </p:sp>
+      <p:sp>
+        <p:nvSpPr>
+          <p:cNvPr id="17" name="Shape 15"/>
+          <p:cNvSpPr/>
+          <p:nvPr/>
+        </p:nvSpPr>
+        <p:spPr>
+          <a:xfrm>
+            <a:off x="640080" y="5257800"/>
+            <a:ext cx="10881360" cy="786384"/>
+          </a:xfrm>
+          <a:prstGeom prst="roundRect">
+            <a:avLst>
+              <a:gd name="adj" fmla="val 6977"/>
+            </a:avLst>
+          </a:prstGeom>
+          <a:solidFill>
+            <a:srgbClr val="FFFFFF"/>
+          </a:solidFill>
+          <a:ln w="12700">
+            <a:solidFill>
+              <a:srgbClr val="E2E8F2"/>
+            </a:solidFill>
+            <a:prstDash val="solid"/>
+          </a:ln>
+          <a:effectLst>
+            <a:outerShdw sx="100000" sy="100000" kx="0" ky="0" algn="bl" rotWithShape="0" blurRad="101600" dist="12700" dir="5400000">
+              <a:srgbClr val="9AA8C0">
+                <a:alpha val="18000"/>
+              </a:srgbClr>
+            </a:outerShdw>
+          </a:effectLst>
+        </p:spPr>
+      </p:sp>
+      <p:sp>
+        <p:nvSpPr>
+          <p:cNvPr id="18" name="Shape 16"/>
+          <p:cNvSpPr/>
+          <p:nvPr/>
+        </p:nvSpPr>
+        <p:spPr>
+          <a:xfrm>
+            <a:off x="914400" y="5440680"/>
+            <a:ext cx="420624" cy="420624"/>
+          </a:xfrm>
+          <a:prstGeom prst="ellipse">
+            <a:avLst/>
+          </a:prstGeom>
+          <a:solidFill>
+            <a:srgbClr val="1E2761"/>
+          </a:solidFill>
+          <a:ln w="12700">
+            <a:solidFill>
+              <a:srgbClr val="1E2761"/>
+            </a:solidFill>
+            <a:prstDash val="solid"/>
+          </a:ln>
+        </p:spPr>
+      </p:sp>
+      <p:sp>
+        <p:nvSpPr>
+          <p:cNvPr id="19" name="Text 17"/>
+          <p:cNvSpPr/>
+          <p:nvPr/>
+        </p:nvSpPr>
+        <p:spPr>
+          <a:xfrm>
+            <a:off x="914400" y="5440680"/>
+            <a:ext cx="420624" cy="420624"/>
+          </a:xfrm>
+          <a:prstGeom prst="rect">
+            <a:avLst/>
+          </a:prstGeom>
+          <a:noFill/>
+          <a:ln/>
+        </p:spPr>
+        <p:txBody>
+          <a:bodyPr wrap="square" lIns="0" tIns="0" rIns="0" bIns="0" rtlCol="0" anchor="ctr"/>
+          <a:lstStyle/>
+          <a:p>
+            <a:pPr algn="ctr" indent="0" marL="0">
+              <a:buNone/>
+            </a:pPr>
+            <a:r>
+              <a:rPr lang="en-US" sz="1500" b="1" dirty="0">
+                <a:solidFill>
+                  <a:srgbClr val="FFFFFF"/>
                 </a:solidFill>
                 <a:latin typeface="Calibri" pitchFamily="34" charset="0"/>
                 <a:ea typeface="Calibri" pitchFamily="34" charset="-122"/>
                 <a:cs typeface="Calibri" pitchFamily="34" charset="-120"/>
               </a:rPr>
-              <a:t>Milestone for the next round: proving live returns on deployed capital with verified execution.</a:t>
+              <a:t>3</a:t>
+            </a:r>
+            <a:endParaRPr lang="en-US" sz="1500" dirty="0"/>
+          </a:p>
+        </p:txBody>
+      </p:sp>
+      <p:sp>
+        <p:nvSpPr>
+          <p:cNvPr id="20" name="Text 18"/>
+          <p:cNvSpPr/>
+          <p:nvPr/>
+        </p:nvSpPr>
+        <p:spPr>
+          <a:xfrm>
+            <a:off x="1517904" y="5367528"/>
+            <a:ext cx="2651760" cy="320040"/>
+          </a:xfrm>
+          <a:prstGeom prst="rect">
+            <a:avLst/>
+          </a:prstGeom>
+          <a:noFill/>
+          <a:ln/>
+        </p:spPr>
+        <p:txBody>
+          <a:bodyPr wrap="square" lIns="0" tIns="0" rIns="0" bIns="0" rtlCol="0" anchor="ctr"/>
+          <a:lstStyle/>
+          <a:p>
+            <a:pPr indent="0" marL="0">
+              <a:buNone/>
+            </a:pPr>
+            <a:r>
+              <a:rPr lang="en-US" sz="1400" b="1" dirty="0">
+                <a:solidFill>
+                  <a:srgbClr val="1E2761"/>
+                </a:solidFill>
+                <a:latin typeface="Calibri" pitchFamily="34" charset="0"/>
+                <a:ea typeface="Calibri" pitchFamily="34" charset="-122"/>
+                <a:cs typeface="Calibri" pitchFamily="34" charset="-120"/>
+              </a:rPr>
+              <a:t>Forward record</a:t>
+            </a:r>
+            <a:endParaRPr lang="en-US" sz="1400" dirty="0"/>
+          </a:p>
+        </p:txBody>
+      </p:sp>
+      <p:sp>
+        <p:nvSpPr>
+          <p:cNvPr id="21" name="Text 19"/>
+          <p:cNvSpPr/>
+          <p:nvPr/>
+        </p:nvSpPr>
+        <p:spPr>
+          <a:xfrm>
+            <a:off x="4114800" y="5367528"/>
+            <a:ext cx="7132320" cy="566928"/>
+          </a:xfrm>
+          <a:prstGeom prst="rect">
+            <a:avLst/>
+          </a:prstGeom>
+          <a:noFill/>
+          <a:ln/>
+        </p:spPr>
+        <p:txBody>
+          <a:bodyPr wrap="square" lIns="0" tIns="0" rIns="0" bIns="0" rtlCol="0" anchor="ctr"/>
+          <a:lstStyle/>
+          <a:p>
+            <a:pPr indent="0" marL="0">
+              <a:buNone/>
+            </a:pPr>
+            <a:r>
+              <a:rPr lang="en-US" sz="1150" dirty="0">
+                <a:solidFill>
+                  <a:srgbClr val="5A6B8C"/>
+                </a:solidFill>
+                <a:latin typeface="Calibri" pitchFamily="34" charset="0"/>
+                <a:ea typeface="Calibri" pitchFamily="34" charset="-122"/>
+                <a:cs typeface="Calibri" pitchFamily="34" charset="-120"/>
+              </a:rPr>
+              <a:t>Continuous paper trading with published, provenance-stamped results and closed trades.</a:t>
+            </a:r>
+            <a:endParaRPr lang="en-US" sz="1150" dirty="0"/>
+          </a:p>
+        </p:txBody>
+      </p:sp>
+      <p:sp>
+        <p:nvSpPr>
+          <p:cNvPr id="22" name="Text 20"/>
+          <p:cNvSpPr/>
+          <p:nvPr/>
+        </p:nvSpPr>
+        <p:spPr>
+          <a:xfrm>
+            <a:off x="640080" y="6172200"/>
+            <a:ext cx="10881360" cy="365760"/>
+          </a:xfrm>
+          <a:prstGeom prst="rect">
+            <a:avLst/>
+          </a:prstGeom>
+          <a:noFill/>
+          <a:ln/>
+        </p:spPr>
+        <p:txBody>
+          <a:bodyPr wrap="square" lIns="0" tIns="0" rIns="0" bIns="0" rtlCol="0" anchor="ctr"/>
+          <a:lstStyle/>
+          <a:p>
+            <a:pPr indent="0" marL="0">
+              <a:buNone/>
+            </a:pPr>
+            <a:r>
+              <a:rPr lang="en-US" sz="1250" b="1" dirty="0">
+                <a:solidFill>
+                  <a:srgbClr val="1E2761"/>
+                </a:solidFill>
+                <a:latin typeface="Calibri" pitchFamily="34" charset="0"/>
+                <a:ea typeface="Calibri" pitchFamily="34" charset="-122"/>
+                <a:cs typeface="Calibri" pitchFamily="34" charset="-120"/>
+              </a:rPr>
+              <a:t>Milestone for the next round: a walk-forward result across at least one adverse regime, published in full.</a:t>
             </a:r>
             <a:endParaRPr lang="en-US" sz="1250" dirty="0"/>
           </a:p>

</xml_diff>